<commit_message>
feat: apply eaLnBrk=0 to prevent Korean word breaks in PPT slides
</commit_message>
<xml_diff>
--- a/public/default_template.pptx
+++ b/public/default_template.pptx
@@ -1224,7 +1224,7 @@
           <a:bodyPr rtlCol="0" anchor="ctr"/>
           <a:lstStyle/>
           <a:p>
-            <a:pPr algn="ctr"/>
+            <a:pPr algn="ctr" eaLnBrk="0"/>
             <a:endParaRPr kumimoji="1" lang="ko-KR" altLang="en-US" dirty="0"/>
           </a:p>
         </p:txBody>
@@ -1257,7 +1257,7 @@
           </a:bodyPr>
           <a:lstStyle/>
           <a:p>
-            <a:pPr algn="l"/>
+            <a:pPr algn="l" eaLnBrk="0"/>
             <a:r>
               <a:rPr lang="en-US" altLang="ko-KR" sz="4800" dirty="0"/>
               <a:t>(CONTENT)</a:t>

</xml_diff>

<commit_message>
fix: maintain Kinsoku rules (eaLnBrk=1) and disable mid-word wrapping (latinLnBrk=0)
</commit_message>
<xml_diff>
--- a/public/default_template.pptx
+++ b/public/default_template.pptx
@@ -1224,7 +1224,7 @@
           <a:bodyPr rtlCol="0" anchor="ctr"/>
           <a:lstStyle/>
           <a:p>
-            <a:pPr algn="ctr" eaLnBrk="0"/>
+            <a:pPr algn="ctr" eaLnBrk="1" latinLnBrk="0"/>
             <a:endParaRPr kumimoji="1" lang="ko-KR" altLang="en-US" dirty="0"/>
           </a:p>
         </p:txBody>
@@ -1257,7 +1257,7 @@
           </a:bodyPr>
           <a:lstStyle/>
           <a:p>
-            <a:pPr algn="l" eaLnBrk="0"/>
+            <a:pPr algn="l" eaLnBrk="1" latinLnBrk="0"/>
             <a:r>
               <a:rPr lang="en-US" altLang="ko-KR" sz="4800" dirty="0"/>
               <a:t>(CONTENT)</a:t>

</xml_diff>